<commit_message>
Regroupement des typologies Pureview + changement des titres
</commit_message>
<xml_diff>
--- a/template_slide.pptx
+++ b/template_slide.pptx
@@ -61,15 +61,6 @@
 
 <file path=ppt/changesInfos/changesInfo1.xml><?xml version="1.0" encoding="utf-8"?>
 <pc:chgInfo xmlns:a="http://schemas.openxmlformats.org/drawingml/2006/main" xmlns:r="http://schemas.openxmlformats.org/officeDocument/2006/relationships" xmlns:ac="http://schemas.microsoft.com/office/drawing/2013/main/command" xmlns:pc="http://schemas.microsoft.com/office/powerpoint/2013/main/command">
-  <pc:docChgLst>
-    <pc:chgData name="GUITTON Marceau" userId="431b00e7-2bde-4f93-bc95-ed2f7df7582d" providerId="ADAL" clId="{EB942D0C-2F24-47EE-A0E0-274DFB167F6F}"/>
-    <pc:docChg chg="undo redo custSel addSld delSld modSld sldOrd modMainMaster">
-      <pc:chgData name="GUITTON Marceau" userId="431b00e7-2bde-4f93-bc95-ed2f7df7582d" providerId="ADAL" clId="{EB942D0C-2F24-47EE-A0E0-274DFB167F6F}" dt="2026-06-01T08:25:04.691" v="13671" actId="20577"/>
-      <pc:docMkLst>
-        <pc:docMk/>
-      </pc:docMkLst>
-    </pc:docChg>
-  </pc:docChgLst>
   <pc:docChgLst>
     <pc:chgData name="RADECKI Léonard" userId="f29644e8-c89e-4636-8512-d50084d68e2d" providerId="ADAL" clId="{481D51FE-A617-40A5-B8C0-F4E503F01039}"/>
     <pc:docChg chg="undo custSel addSld delSld modSld sldOrd">
@@ -401,6 +392,15 @@
       </pc:sldChg>
     </pc:docChg>
   </pc:docChgLst>
+  <pc:docChgLst>
+    <pc:chgData name="GUITTON Marceau" userId="431b00e7-2bde-4f93-bc95-ed2f7df7582d" providerId="ADAL" clId="{EB942D0C-2F24-47EE-A0E0-274DFB167F6F}"/>
+    <pc:docChg chg="undo redo custSel addSld delSld modSld sldOrd modMainMaster">
+      <pc:chgData name="GUITTON Marceau" userId="431b00e7-2bde-4f93-bc95-ed2f7df7582d" providerId="ADAL" clId="{EB942D0C-2F24-47EE-A0E0-274DFB167F6F}" dt="2026-06-01T08:25:04.691" v="13671" actId="20577"/>
+      <pc:docMkLst>
+        <pc:docMk/>
+      </pc:docMkLst>
+    </pc:docChg>
+  </pc:docChgLst>
 </pc:chgInfo>
 </file>
 
@@ -498,7 +498,7 @@
           <a:p>
             <a:fld id="{1C398B18-1FC9-4CA0-A7D6-81F47BD37093}" type="datetimeFigureOut">
               <a:rPr lang="fr-FR" smtClean="0"/>
-              <a:t>29/06/2026</a:t>
+              <a:t>28/07/2026</a:t>
             </a:fld>
             <a:endParaRPr lang="fr-FR"/>
           </a:p>
@@ -576,7 +576,7 @@
           <a:p>
             <a:fld id="{6B85378B-C51C-4266-9A0D-0EDE21A31927}" type="slidenum">
               <a:rPr lang="fr-FR" smtClean="0"/>
-              <a:t>‹N°›</a:t>
+              <a:t>‹#›</a:t>
             </a:fld>
             <a:endParaRPr lang="fr-FR"/>
           </a:p>
@@ -676,7 +676,7 @@
           <a:p>
             <a:fld id="{34FA201B-1923-41C6-9CFC-D952B314DDF4}" type="datetimeFigureOut">
               <a:rPr lang="fr-FR" smtClean="0"/>
-              <a:t>29/06/2026</a:t>
+              <a:t>28/07/2026</a:t>
             </a:fld>
             <a:endParaRPr lang="fr-FR"/>
           </a:p>
@@ -834,7 +834,7 @@
           <a:p>
             <a:fld id="{5DB62E08-07A8-41F2-BC05-2A07CCB032C9}" type="slidenum">
               <a:rPr lang="fr-FR" smtClean="0"/>
-              <a:t>‹N°›</a:t>
+              <a:t>‹#›</a:t>
             </a:fld>
             <a:endParaRPr lang="fr-FR"/>
           </a:p>
@@ -1657,7 +1657,7 @@
                   <a:spcPts val="250"/>
                 </a:spcBef>
               </a:pPr>
-              <a:t>‹N°›</a:t>
+              <a:t>‹#›</a:t>
             </a:fld>
             <a:endParaRPr lang="fr-FR"/>
           </a:p>
@@ -1756,7 +1756,7 @@
           <a:p>
             <a:fld id="{264D35D0-50BB-43BE-A101-1F7EB7759A12}" type="datetime1">
               <a:rPr lang="fr-FR" smtClean="0"/>
-              <a:t>29/06/2026</a:t>
+              <a:t>28/07/2026</a:t>
             </a:fld>
             <a:endParaRPr lang="en-US"/>
           </a:p>
@@ -1956,7 +1956,7 @@
                   <a:spcPts val="250"/>
                 </a:spcBef>
               </a:pPr>
-              <a:t>‹N°›</a:t>
+              <a:t>‹#›</a:t>
             </a:fld>
             <a:endParaRPr lang="fr-FR"/>
           </a:p>
@@ -2055,7 +2055,7 @@
           <a:p>
             <a:fld id="{63781C26-28C2-45CD-9987-59E4E1A896AC}" type="datetime1">
               <a:rPr lang="fr-FR" smtClean="0"/>
-              <a:t>29/06/2026</a:t>
+              <a:t>28/07/2026</a:t>
             </a:fld>
             <a:endParaRPr lang="en-US"/>
           </a:p>
@@ -2363,7 +2363,7 @@
                   <a:spcPts val="250"/>
                 </a:spcBef>
               </a:pPr>
-              <a:t>‹N°›</a:t>
+              <a:t>‹#›</a:t>
             </a:fld>
             <a:endParaRPr lang="fr-FR"/>
           </a:p>
@@ -2462,7 +2462,7 @@
           <a:p>
             <a:fld id="{6969951E-151E-47FC-A8E9-762EBABC7BB2}" type="datetime1">
               <a:rPr lang="fr-FR" smtClean="0"/>
-              <a:t>29/06/2026</a:t>
+              <a:t>28/07/2026</a:t>
             </a:fld>
             <a:endParaRPr lang="en-US"/>
           </a:p>
@@ -2727,7 +2727,7 @@
                   <a:spcPts val="250"/>
                 </a:spcBef>
               </a:pPr>
-              <a:t>‹N°›</a:t>
+              <a:t>‹#›</a:t>
             </a:fld>
             <a:endParaRPr lang="fr-FR"/>
           </a:p>
@@ -2826,7 +2826,7 @@
           <a:p>
             <a:fld id="{21E5ACA5-C3C6-4F99-92E2-D375171F12BF}" type="datetime1">
               <a:rPr lang="fr-FR" smtClean="0"/>
-              <a:t>29/06/2026</a:t>
+              <a:t>28/07/2026</a:t>
             </a:fld>
             <a:endParaRPr lang="en-US"/>
           </a:p>
@@ -3100,7 +3100,7 @@
           <a:p>
             <a:fld id="{47CB6DF1-2B16-43E4-A0BF-E70DEAE425AC}" type="datetime1">
               <a:rPr lang="fr-FR" smtClean="0"/>
-              <a:t>29/06/2026</a:t>
+              <a:t>28/07/2026</a:t>
             </a:fld>
             <a:endParaRPr lang="en-US"/>
           </a:p>
@@ -3157,7 +3157,7 @@
                   <a:spcPts val="250"/>
                 </a:spcBef>
               </a:pPr>
-              <a:t>‹N°›</a:t>
+              <a:t>‹#›</a:t>
             </a:fld>
             <a:endParaRPr lang="fr-FR"/>
           </a:p>
@@ -3475,7 +3475,7 @@
           <a:p>
             <a:fld id="{18B9993B-AA06-4FC4-8088-2FEB68083F8A}" type="datetime1">
               <a:rPr lang="fr-FR" smtClean="0"/>
-              <a:t>29/06/2026</a:t>
+              <a:t>28/07/2026</a:t>
             </a:fld>
             <a:endParaRPr lang="en-US"/>
           </a:p>
@@ -6015,7 +6015,10 @@
           <a:bodyPr/>
           <a:lstStyle/>
           <a:p>
-            <a:endParaRPr lang="fr-FR"/>
+            <a:r>
+              <a:rPr lang="fr-FR" dirty="0"/>
+              <a:t>Les incidents du mois par source de log et par occurrence</a:t>
+            </a:r>
           </a:p>
         </p:txBody>
       </p:sp>
@@ -6042,7 +6045,7 @@
           <a:p>
             <a:r>
               <a:rPr lang="fr-FR" dirty="0"/>
-              <a:t>Evolution des incidents par typologie</a:t>
+              <a:t>ETAT DE LA SURVEILLANCE</a:t>
             </a:r>
           </a:p>
         </p:txBody>
@@ -6137,7 +6140,7 @@
           <a:p>
             <a:fld id="{264D35D0-50BB-43BE-A101-1F7EB7759A12}" type="datetime1">
               <a:rPr lang="fr-FR" smtClean="0"/>
-              <a:t>29/06/2026</a:t>
+              <a:t>28/07/2026</a:t>
             </a:fld>
             <a:endParaRPr lang="en-US"/>
           </a:p>
@@ -6194,7 +6197,10 @@
           <a:bodyPr/>
           <a:lstStyle/>
           <a:p>
-            <a:endParaRPr lang="fr-FR"/>
+            <a:r>
+              <a:rPr lang="fr-FR" dirty="0"/>
+              <a:t>Les incidents du mois</a:t>
+            </a:r>
           </a:p>
         </p:txBody>
       </p:sp>
@@ -6221,7 +6227,7 @@
           <a:p>
             <a:r>
               <a:rPr lang="fr-FR" dirty="0"/>
-              <a:t>Les Incidents du mois</a:t>
+              <a:t>ETAT DE LA SURVEILLANCE</a:t>
             </a:r>
           </a:p>
         </p:txBody>
@@ -6317,7 +6323,7 @@
           <a:p>
             <a:fld id="{264D35D0-50BB-43BE-A101-1F7EB7759A12}" type="datetime1">
               <a:rPr lang="fr-FR" smtClean="0"/>
-              <a:t>29/06/2026</a:t>
+              <a:t>28/07/2026</a:t>
             </a:fld>
             <a:endParaRPr lang="en-US"/>
           </a:p>
@@ -6374,7 +6380,10 @@
           <a:bodyPr/>
           <a:lstStyle/>
           <a:p>
-            <a:endParaRPr lang="fr-FR"/>
+            <a:r>
+              <a:rPr lang="fr-FR" dirty="0"/>
+              <a:t>Dépassement des SLA</a:t>
+            </a:r>
           </a:p>
         </p:txBody>
       </p:sp>
@@ -6400,10 +6409,9 @@
           <a:lstStyle/>
           <a:p>
             <a:r>
-              <a:rPr lang="fr-FR"/>
-              <a:t>Dépassement des SLA</a:t>
-            </a:r>
-            <a:endParaRPr lang="fr-FR" dirty="0"/>
+              <a:rPr lang="fr-FR" dirty="0"/>
+              <a:t>ETAT DE LA SURVEILLANCE</a:t>
+            </a:r>
           </a:p>
         </p:txBody>
       </p:sp>
@@ -6497,7 +6505,7 @@
           <a:p>
             <a:fld id="{264D35D0-50BB-43BE-A101-1F7EB7759A12}" type="datetime1">
               <a:rPr lang="fr-FR" smtClean="0"/>
-              <a:t>29/06/2026</a:t>
+              <a:t>28/07/2026</a:t>
             </a:fld>
             <a:endParaRPr lang="en-US"/>
           </a:p>
@@ -6562,7 +6570,7 @@
           <a:p>
             <a:r>
               <a:rPr lang="fr-FR" dirty="0"/>
-              <a:t>Dispositif de surveillance</a:t>
+              <a:t>ETAT DE LA SURVEILLANCE</a:t>
             </a:r>
           </a:p>
         </p:txBody>
@@ -6618,7 +6626,7 @@
           <a:p>
             <a:fld id="{C602464E-C014-458D-AAF3-4161D816C79F}" type="datetime1">
               <a:rPr lang="fr-FR" smtClean="0"/>
-              <a:t>29/06/2026</a:t>
+              <a:t>28/07/2026</a:t>
             </a:fld>
             <a:endParaRPr lang="en-US"/>
           </a:p>
@@ -9014,7 +9022,7 @@
           <a:p>
             <a:r>
               <a:rPr lang="fr-FR" dirty="0"/>
-              <a:t>Plan de collecte</a:t>
+              <a:t>ETAT DE LA SURVEILLANCE</a:t>
             </a:r>
           </a:p>
         </p:txBody>
@@ -9070,7 +9078,7 @@
           <a:p>
             <a:fld id="{26205C61-3EB2-4801-AF6F-32AEC63420F3}" type="datetime1">
               <a:rPr lang="fr-FR" smtClean="0"/>
-              <a:t>29/06/2026</a:t>
+              <a:t>28/07/2026</a:t>
             </a:fld>
             <a:endParaRPr lang="en-US"/>
           </a:p>
@@ -10075,15 +10083,6 @@
 </file>
 
 <file path=customXml/item1.xml><?xml version="1.0" encoding="utf-8"?>
-<?mso-contentType ?>
-<FormTemplates xmlns="http://schemas.microsoft.com/sharepoint/v3/contenttype/forms">
-  <Display>DocumentLibraryForm</Display>
-  <Edit>DocumentLibraryForm</Edit>
-  <New>DocumentLibraryForm</New>
-</FormTemplates>
-</file>
-
-<file path=customXml/item2.xml><?xml version="1.0" encoding="utf-8"?>
 <p:properties xmlns:p="http://schemas.microsoft.com/office/2006/metadata/properties" xmlns:xsi="http://www.w3.org/2001/XMLSchema-instance" xmlns:pc="http://schemas.microsoft.com/office/infopath/2007/PartnerControls">
   <documentManagement>
     <lcf76f155ced4ddcb4097134ff3c332f xmlns="fb7f30b7-2c0d-427f-bf97-607d9ff5a17d">
@@ -10091,6 +10090,15 @@
     </lcf76f155ced4ddcb4097134ff3c332f>
   </documentManagement>
 </p:properties>
+</file>
+
+<file path=customXml/item2.xml><?xml version="1.0" encoding="utf-8"?>
+<?mso-contentType ?>
+<FormTemplates xmlns="http://schemas.microsoft.com/sharepoint/v3/contenttype/forms">
+  <Display>DocumentLibraryForm</Display>
+  <Edit>DocumentLibraryForm</Edit>
+  <New>DocumentLibraryForm</New>
+</FormTemplates>
 </file>
 
 <file path=customXml/item3.xml><?xml version="1.0" encoding="utf-8"?>
@@ -10272,14 +10280,6 @@
 </file>
 
 <file path=customXml/itemProps1.xml><?xml version="1.0" encoding="utf-8"?>
-<ds:datastoreItem xmlns:ds="http://schemas.openxmlformats.org/officeDocument/2006/customXml" ds:itemID="{2620397C-37FD-4D83-9575-67D67C3A4ECA}">
-  <ds:schemaRefs>
-    <ds:schemaRef ds:uri="http://schemas.microsoft.com/sharepoint/v3/contenttype/forms"/>
-  </ds:schemaRefs>
-</ds:datastoreItem>
-</file>
-
-<file path=customXml/itemProps2.xml><?xml version="1.0" encoding="utf-8"?>
 <ds:datastoreItem xmlns:ds="http://schemas.openxmlformats.org/officeDocument/2006/customXml" ds:itemID="{62A8DBFC-4892-4B48-85A4-9F78BBFA76B0}">
   <ds:schemaRefs>
     <ds:schemaRef ds:uri="http://schemas.microsoft.com/office/2006/documentManagement/types"/>
@@ -10291,6 +10291,14 @@
     <ds:schemaRef ds:uri="http://schemas.microsoft.com/office/infopath/2007/PartnerControls"/>
     <ds:schemaRef ds:uri="fb7f30b7-2c0d-427f-bf97-607d9ff5a17d"/>
     <ds:schemaRef ds:uri="http://www.w3.org/XML/1998/namespace"/>
+  </ds:schemaRefs>
+</ds:datastoreItem>
+</file>
+
+<file path=customXml/itemProps2.xml><?xml version="1.0" encoding="utf-8"?>
+<ds:datastoreItem xmlns:ds="http://schemas.openxmlformats.org/officeDocument/2006/customXml" ds:itemID="{2620397C-37FD-4D83-9575-67D67C3A4ECA}">
+  <ds:schemaRefs>
+    <ds:schemaRef ds:uri="http://schemas.microsoft.com/sharepoint/v3/contenttype/forms"/>
   </ds:schemaRefs>
 </ds:datastoreItem>
 </file>

</xml_diff>